<commit_message>
Integración de PostgreSQL, corrección de modelos Gemini y estilos de Streamlit
</commit_message>
<xml_diff>
--- a/backend/documents/presentacion_empresa.pptx
+++ b/backend/documents/presentacion_empresa.pptx
@@ -3367,7 +3367,7 @@
           <a:p>
             <a:pPr/>
             <a:r>
-              <a:t>Atención al Cliente (Soporte 24/7)</a:t>
+              <a:t>Atención al Cliente (Soporte L-V 9:00-18:00 y Sáb 10:00-14:00)</a:t>
             </a:r>
           </a:p>
           <a:p>
@@ -3539,7 +3539,7 @@
           <a:p>
             <a:pPr/>
             <a:r>
-              <a:t>Teléfono: 800-AMERSHOP</a:t>
+              <a:t>Teléfono: +52-800-AMERSHOP</a:t>
             </a:r>
           </a:p>
           <a:p>

</xml_diff>